<commit_message>
Pilot: USA Population PW1 with a deeper board summary
Four mapping methods (dot, choropleth, isopleth, proportional symbols), the
Lorenz curve and the density lapse rate, each on its own slide with its
diagram beside the text, followed by advantages and disadvantages. The
situation now states the problem, and the activities lead learners to
discover each technique. Generator: figure slides for summary points with a
picture, bulleted lists under a term, headings never left alone at the
bottom of a slide.

Co-Authored-By: Claude Opus 5.5 <noreply@anthropic.com>
Claude-Session: https://claude.ai/code/session_0115LFSb2ktGLWPeVksFkSer
</commit_message>
<xml_diff>
--- a/lecons/USA/Population Geography/04_USA_POP_L03_Spatial_Population_Distribution_and_its_Factors.pptx
+++ b/lecons/USA/Population Geography/04_USA_POP_L03_Spatial_Population_Distribution_and_its_Factors.pptx
@@ -3461,7 +3461,7 @@
           <a:p>
             <a:r>
               <a:rPr lang="en-US" dirty="0"/>
-              <a:t>Before we start the new lesson, let us correct the homework I gave you at the end of Practical Work 1: Techniques of Mapping Population Distribution and Density. The question was: Using the density figures of the ten regions, draw a choropleth map of Cameroon with four classes. Take out your exercise books.</a:t>
+              <a:t>Before we start the new lesson, let us correct the homework I gave you at the end of Practical Work 1: Techniques of Mapping Population Distribution and Density. The question was: Explain why a choropleth map of the North Region might be misleading, even if the data are correct. Take out your exercise books.</a:t>
             </a:r>
             <a:endParaRPr lang="en-US" dirty="0"/>
           </a:p>
@@ -4429,7 +4429,7 @@
           <a:p>
             <a:r>
               <a:rPr lang="en-US" dirty="0"/>
-              <a:t>Here is a good answer. Classes (example): below 25, 25–50, 50–100, over 100 people/km². Littoral, West, North-West and Far North are darkest; East, South and Adamawa are lightest. Compare it with your own answer and correct your work in red.</a:t>
+              <a:t>Here is a good answer. It gives one average density to each division, so it hides crowded towns such as Garoua and almost empty areas such as the national parks inside the same division. The sharp change of shade at each boundary also suggests changes that do not exist on the ground. Compare it with your own answer and correct your work in red.</a:t>
             </a:r>
             <a:endParaRPr lang="en-US" dirty="0"/>
           </a:p>
@@ -15230,7 +15230,7 @@
                 <a:ea typeface="Times New Roman" pitchFamily="34" charset="-122"/>
                 <a:cs typeface="Times New Roman" pitchFamily="34" charset="-120"/>
               </a:rPr>
-              <a:t>Using the density figures of the ten regions, draw a choropleth map of Cameroon with four classes.</a:t>
+              <a:t>Explain why a choropleth map of the North Region might be misleading, even if the data are correct.</a:t>
             </a:r>
             <a:endParaRPr lang="en-US" sz="4000" dirty="0"/>
           </a:p>
@@ -17726,7 +17726,7 @@
         <p:spPr>
           <a:xfrm>
             <a:off x="0" y="658368"/>
-            <a:ext cx="5120640" cy="5833872"/>
+            <a:ext cx="2468880" cy="5833872"/>
           </a:xfrm>
           <a:prstGeom prst="rect">
             <a:avLst/>
@@ -17741,8 +17741,8 @@
         </p:nvSpPr>
         <p:spPr>
           <a:xfrm>
-            <a:off x="5349240" y="1005840"/>
-            <a:ext cx="6522415" cy="731520"/>
+            <a:off x="2697480" y="1005840"/>
+            <a:ext cx="9174175" cy="731520"/>
           </a:xfrm>
           <a:prstGeom prst="rect">
             <a:avLst/>
@@ -17782,8 +17782,8 @@
         </p:nvSpPr>
         <p:spPr>
           <a:xfrm>
-            <a:off x="5349240" y="1783080"/>
-            <a:ext cx="6522415" cy="4663440"/>
+            <a:off x="2697480" y="1783080"/>
+            <a:ext cx="9174175" cy="4663440"/>
           </a:xfrm>
           <a:prstGeom prst="rect">
             <a:avLst/>
@@ -17810,7 +17810,7 @@
                 <a:ea typeface="Times New Roman" pitchFamily="34" charset="-122"/>
                 <a:cs typeface="Times New Roman" pitchFamily="34" charset="-120"/>
               </a:rPr>
-              <a:t>Classes (example): below 25, 25–50, 50–100, over 100 people/km². Littoral, West, North-West and Far North are darkest; East, South and Adamawa are lightest.</a:t>
+              <a:t>It gives one average density to each division, so it hides crowded towns such as Garoua and almost empty areas such as the national parks inside the same division. The sharp change of shade at each boundary also suggests changes that do not exist on the ground.</a:t>
             </a:r>
             <a:endParaRPr lang="en-US" sz="4000" dirty="0"/>
           </a:p>

</xml_diff>